<commit_message>
added mortage value check
</commit_message>
<xml_diff>
--- a/assets-helper/real_estate_cards.pptx
+++ b/assets-helper/real_estate_cards.pptx
@@ -35,7 +35,7 @@
     <p:sldId id="283" r:id="rId29"/>
   </p:sldIdLst>
   <p:sldSz cx="6858000" cy="9906000" type="A4"/>
-  <p:notesSz cx="6858000" cy="9144000"/>
+  <p:notesSz cx="7104063" cy="10234613"/>
   <p:defaultTextStyle>
     <a:defPPr>
       <a:defRPr lang="en-US"/>
@@ -270,7 +270,7 @@
           <a:p>
             <a:fld id="{115FE0BD-F28D-4EAF-ACCC-3D8ABD420A72}" type="datetimeFigureOut">
               <a:rPr lang="de-DE" smtClean="0"/>
-              <a:t>28.05.23</a:t>
+              <a:t>28.07.2025</a:t>
             </a:fld>
             <a:endParaRPr lang="de-DE"/>
           </a:p>
@@ -440,7 +440,7 @@
           <a:p>
             <a:fld id="{115FE0BD-F28D-4EAF-ACCC-3D8ABD420A72}" type="datetimeFigureOut">
               <a:rPr lang="de-DE" smtClean="0"/>
-              <a:t>28.05.23</a:t>
+              <a:t>28.07.2025</a:t>
             </a:fld>
             <a:endParaRPr lang="de-DE"/>
           </a:p>
@@ -620,7 +620,7 @@
           <a:p>
             <a:fld id="{115FE0BD-F28D-4EAF-ACCC-3D8ABD420A72}" type="datetimeFigureOut">
               <a:rPr lang="de-DE" smtClean="0"/>
-              <a:t>28.05.23</a:t>
+              <a:t>28.07.2025</a:t>
             </a:fld>
             <a:endParaRPr lang="de-DE"/>
           </a:p>
@@ -790,7 +790,7 @@
           <a:p>
             <a:fld id="{115FE0BD-F28D-4EAF-ACCC-3D8ABD420A72}" type="datetimeFigureOut">
               <a:rPr lang="de-DE" smtClean="0"/>
-              <a:t>28.05.23</a:t>
+              <a:t>28.07.2025</a:t>
             </a:fld>
             <a:endParaRPr lang="de-DE"/>
           </a:p>
@@ -1034,7 +1034,7 @@
           <a:p>
             <a:fld id="{115FE0BD-F28D-4EAF-ACCC-3D8ABD420A72}" type="datetimeFigureOut">
               <a:rPr lang="de-DE" smtClean="0"/>
-              <a:t>28.05.23</a:t>
+              <a:t>28.07.2025</a:t>
             </a:fld>
             <a:endParaRPr lang="de-DE"/>
           </a:p>
@@ -1266,7 +1266,7 @@
           <a:p>
             <a:fld id="{115FE0BD-F28D-4EAF-ACCC-3D8ABD420A72}" type="datetimeFigureOut">
               <a:rPr lang="de-DE" smtClean="0"/>
-              <a:t>28.05.23</a:t>
+              <a:t>28.07.2025</a:t>
             </a:fld>
             <a:endParaRPr lang="de-DE"/>
           </a:p>
@@ -1633,7 +1633,7 @@
           <a:p>
             <a:fld id="{115FE0BD-F28D-4EAF-ACCC-3D8ABD420A72}" type="datetimeFigureOut">
               <a:rPr lang="de-DE" smtClean="0"/>
-              <a:t>28.05.23</a:t>
+              <a:t>28.07.2025</a:t>
             </a:fld>
             <a:endParaRPr lang="de-DE"/>
           </a:p>
@@ -1751,7 +1751,7 @@
           <a:p>
             <a:fld id="{115FE0BD-F28D-4EAF-ACCC-3D8ABD420A72}" type="datetimeFigureOut">
               <a:rPr lang="de-DE" smtClean="0"/>
-              <a:t>28.05.23</a:t>
+              <a:t>28.07.2025</a:t>
             </a:fld>
             <a:endParaRPr lang="de-DE"/>
           </a:p>
@@ -1846,7 +1846,7 @@
           <a:p>
             <a:fld id="{115FE0BD-F28D-4EAF-ACCC-3D8ABD420A72}" type="datetimeFigureOut">
               <a:rPr lang="de-DE" smtClean="0"/>
-              <a:t>28.05.23</a:t>
+              <a:t>28.07.2025</a:t>
             </a:fld>
             <a:endParaRPr lang="de-DE"/>
           </a:p>
@@ -2123,7 +2123,7 @@
           <a:p>
             <a:fld id="{115FE0BD-F28D-4EAF-ACCC-3D8ABD420A72}" type="datetimeFigureOut">
               <a:rPr lang="de-DE" smtClean="0"/>
-              <a:t>28.05.23</a:t>
+              <a:t>28.07.2025</a:t>
             </a:fld>
             <a:endParaRPr lang="de-DE"/>
           </a:p>
@@ -2380,7 +2380,7 @@
           <a:p>
             <a:fld id="{115FE0BD-F28D-4EAF-ACCC-3D8ABD420A72}" type="datetimeFigureOut">
               <a:rPr lang="de-DE" smtClean="0"/>
-              <a:t>28.05.23</a:t>
+              <a:t>28.07.2025</a:t>
             </a:fld>
             <a:endParaRPr lang="de-DE"/>
           </a:p>
@@ -2593,7 +2593,7 @@
           <a:p>
             <a:fld id="{115FE0BD-F28D-4EAF-ACCC-3D8ABD420A72}" type="datetimeFigureOut">
               <a:rPr lang="de-DE" smtClean="0"/>
-              <a:t>28.05.23</a:t>
+              <a:t>28.07.2025</a:t>
             </a:fld>
             <a:endParaRPr lang="de-DE"/>
           </a:p>
@@ -11555,7 +11555,7 @@
           <a:p>
             <a:r>
               <a:rPr lang="de-DE" b="1" dirty="0"/>
-              <a:t>Bahnhofstraße</a:t>
+              <a:t>Hauptstraße</a:t>
             </a:r>
           </a:p>
         </p:txBody>
@@ -13247,7 +13247,7 @@
           <a:p>
             <a:r>
               <a:rPr lang="de-DE" b="1" dirty="0"/>
-              <a:t>Hauptstraße</a:t>
+              <a:t>Bahnhofstraße</a:t>
             </a:r>
           </a:p>
         </p:txBody>

</xml_diff>